<commit_message>
Invitación del taller: subtítulo del juego de café y fila de qué incluye; punto 05 con vino, café y pasabocas
Co-Authored-By: Claude Opus 5.5 <noreply@anthropic.com>
Claude-Session: https://claude.ai/code/session_01FV7y6XEE3x9ogCMyfe3pnd
</commit_message>
<xml_diff>
--- a/docs/sesion-2026-10-02/canva-taller-ceramica/historia-4-invitacion/historias-taller-ceramica.pptx
+++ b/docs/sesion-2026-10-02/canva-taller-ceramica/historia-4-invitacion/historias-taller-ceramica.pptx
@@ -3304,7 +3304,60 @@
         </p:nvSpPr>
         <p:spPr>
           <a:xfrm>
-            <a:off x="609600" y="11849100"/>
+            <a:off x="609600" y="6781800"/>
+            <a:ext cx="4237286" cy="963811"/>
+          </a:xfrm>
+          <a:prstGeom prst="rect">
+            <a:avLst/>
+          </a:prstGeom>
+          <a:noFill/>
+        </p:spPr>
+        <p:txBody>
+          <a:bodyPr wrap="none" anchor="t" lIns="0" rIns="0" tIns="0" bIns="0"/>
+          <a:lstStyle/>
+          <a:p>
+            <a:pPr algn="l">
+              <a:lnSpc>
+                <a:spcPts val="3795"/>
+              </a:lnSpc>
+            </a:pPr>
+            <a:r>
+              <a:rPr sz="3300" b="0" spc="-38">
+                <a:solidFill>
+                  <a:srgbClr val="F3F1EA"/>
+                </a:solidFill>
+                <a:latin typeface="Archivo SemiBold"/>
+              </a:rPr>
+              <a:t>Pinta tu propio juego</a:t>
+            </a:r>
+          </a:p>
+          <a:p>
+            <a:pPr algn="l">
+              <a:lnSpc>
+                <a:spcPts val="3795"/>
+              </a:lnSpc>
+            </a:pPr>
+            <a:r>
+              <a:rPr sz="3300" b="0" spc="-38">
+                <a:solidFill>
+                  <a:srgbClr val="F3F1EA"/>
+                </a:solidFill>
+                <a:latin typeface="Archivo SemiBold"/>
+              </a:rPr>
+              <a:t>de café para cuatro</a:t>
+            </a:r>
+          </a:p>
+        </p:txBody>
+      </p:sp>
+      <p:sp>
+        <p:nvSpPr>
+          <p:cNvPr id="9" name="TextBox 8"/>
+          <p:cNvSpPr txBox="1"/>
+          <p:nvPr/>
+        </p:nvSpPr>
+        <p:spPr>
+          <a:xfrm>
+            <a:off x="609600" y="10706100"/>
             <a:ext cx="3019425" cy="438150"/>
           </a:xfrm>
           <a:prstGeom prst="rect">
@@ -3335,13 +3388,13 @@
       </p:sp>
       <p:sp>
         <p:nvSpPr>
-          <p:cNvPr id="9" name="TextBox 8"/>
+          <p:cNvPr id="10" name="TextBox 9"/>
           <p:cNvSpPr txBox="1"/>
           <p:nvPr/>
         </p:nvSpPr>
         <p:spPr>
           <a:xfrm>
-            <a:off x="3629025" y="11220450"/>
+            <a:off x="3629025" y="10077450"/>
             <a:ext cx="3019425" cy="1066800"/>
           </a:xfrm>
           <a:prstGeom prst="rect">
@@ -3372,13 +3425,13 @@
       </p:sp>
       <p:sp>
         <p:nvSpPr>
-          <p:cNvPr id="10" name="TextBox 9"/>
+          <p:cNvPr id="11" name="TextBox 10"/>
           <p:cNvSpPr txBox="1"/>
           <p:nvPr/>
         </p:nvSpPr>
         <p:spPr>
           <a:xfrm>
-            <a:off x="3629025" y="12420600"/>
+            <a:off x="3629025" y="11277600"/>
             <a:ext cx="3019425" cy="361950"/>
           </a:xfrm>
           <a:prstGeom prst="rect">
@@ -3409,13 +3462,13 @@
       </p:sp>
       <p:sp>
         <p:nvSpPr>
-          <p:cNvPr id="11" name="TextBox 10"/>
+          <p:cNvPr id="12" name="TextBox 11"/>
           <p:cNvSpPr txBox="1"/>
           <p:nvPr/>
         </p:nvSpPr>
         <p:spPr>
           <a:xfrm>
-            <a:off x="6657975" y="11639550"/>
+            <a:off x="6657975" y="10496550"/>
             <a:ext cx="3019425" cy="1000125"/>
           </a:xfrm>
           <a:prstGeom prst="rect">
@@ -3462,13 +3515,13 @@
       </p:sp>
       <p:sp>
         <p:nvSpPr>
-          <p:cNvPr id="12" name="TextBox 11"/>
+          <p:cNvPr id="13" name="TextBox 12"/>
           <p:cNvSpPr txBox="1"/>
           <p:nvPr/>
         </p:nvSpPr>
         <p:spPr>
           <a:xfrm>
-            <a:off x="609600" y="13735050"/>
+            <a:off x="609600" y="12592050"/>
             <a:ext cx="9067800" cy="438150"/>
           </a:xfrm>
           <a:prstGeom prst="rect">
@@ -3499,88 +3552,14 @@
       </p:sp>
       <p:sp>
         <p:nvSpPr>
-          <p:cNvPr id="13" name="TextBox 12"/>
-          <p:cNvSpPr txBox="1"/>
-          <p:nvPr/>
-        </p:nvSpPr>
-        <p:spPr>
-          <a:xfrm>
-            <a:off x="609600" y="14744700"/>
-            <a:ext cx="4533900" cy="228600"/>
-          </a:xfrm>
-          <a:prstGeom prst="rect">
-            <a:avLst/>
-          </a:prstGeom>
-          <a:noFill/>
-        </p:spPr>
-        <p:txBody>
-          <a:bodyPr wrap="none" anchor="t" lIns="0" rIns="0" tIns="0" bIns="0"/>
-          <a:lstStyle/>
-          <a:p>
-            <a:pPr algn="ctr">
-              <a:lnSpc>
-                <a:spcPts val="1800"/>
-              </a:lnSpc>
-            </a:pPr>
-            <a:r>
-              <a:rPr sz="1800" b="0" spc="225">
-                <a:solidFill>
-                  <a:srgbClr val="2E3A46"/>
-                </a:solidFill>
-                <a:latin typeface="Archivo SemiBold"/>
-              </a:rPr>
-              <a:t>POR PERSONA</a:t>
-            </a:r>
-          </a:p>
-        </p:txBody>
-      </p:sp>
-      <p:sp>
-        <p:nvSpPr>
           <p:cNvPr id="14" name="TextBox 13"/>
           <p:cNvSpPr txBox="1"/>
           <p:nvPr/>
         </p:nvSpPr>
         <p:spPr>
           <a:xfrm>
-            <a:off x="609600" y="15087600"/>
-            <a:ext cx="4533900" cy="552450"/>
-          </a:xfrm>
-          <a:prstGeom prst="rect">
-            <a:avLst/>
-          </a:prstGeom>
-          <a:noFill/>
-        </p:spPr>
-        <p:txBody>
-          <a:bodyPr wrap="none" anchor="t" lIns="0" rIns="0" tIns="0" bIns="0"/>
-          <a:lstStyle/>
-          <a:p>
-            <a:pPr algn="ctr">
-              <a:lnSpc>
-                <a:spcPts val="4350"/>
-              </a:lnSpc>
-            </a:pPr>
-            <a:r>
-              <a:rPr sz="4350" b="1" spc="-75">
-                <a:solidFill>
-                  <a:srgbClr val="2E3A46"/>
-                </a:solidFill>
-                <a:latin typeface="Archivo"/>
-              </a:rPr>
-              <a:t>$230.000</a:t>
-            </a:r>
-          </a:p>
-        </p:txBody>
-      </p:sp>
-      <p:sp>
-        <p:nvSpPr>
-          <p:cNvPr id="15" name="TextBox 14"/>
-          <p:cNvSpPr txBox="1"/>
-          <p:nvPr/>
-        </p:nvSpPr>
-        <p:spPr>
-          <a:xfrm>
-            <a:off x="5143500" y="14744700"/>
-            <a:ext cx="4533900" cy="209550"/>
+            <a:off x="609600" y="13582650"/>
+            <a:ext cx="9067800" cy="209550"/>
           </a:xfrm>
           <a:prstGeom prst="rect">
             <a:avLst/>
@@ -3603,21 +3582,21 @@
                 </a:solidFill>
                 <a:latin typeface="Archivo SemiBold"/>
               </a:rPr>
-              <a:t>RESERVAS POR WHATSAPP</a:t>
-            </a:r>
-          </a:p>
-        </p:txBody>
-      </p:sp>
-      <p:sp>
-        <p:nvSpPr>
-          <p:cNvPr id="16" name="TextBox 15"/>
+              <a:t>INCLUYE</a:t>
+            </a:r>
+          </a:p>
+        </p:txBody>
+      </p:sp>
+      <p:sp>
+        <p:nvSpPr>
+          <p:cNvPr id="15" name="TextBox 14"/>
           <p:cNvSpPr txBox="1"/>
           <p:nvPr/>
         </p:nvSpPr>
         <p:spPr>
           <a:xfrm>
-            <a:off x="5143500" y="15125700"/>
-            <a:ext cx="4533900" cy="438150"/>
+            <a:off x="609600" y="13925550"/>
+            <a:ext cx="9067800" cy="361950"/>
           </a:xfrm>
           <a:prstGeom prst="rect">
             <a:avLst/>
@@ -3630,11 +3609,159 @@
           <a:p>
             <a:pPr algn="ctr">
               <a:lnSpc>
-                <a:spcPts val="3450"/>
+                <a:spcPts val="2850"/>
               </a:lnSpc>
             </a:pPr>
             <a:r>
-              <a:rPr sz="3450" b="0">
+              <a:rPr sz="2850" b="0" spc="-22">
+                <a:solidFill>
+                  <a:srgbClr val="2E3A46"/>
+                </a:solidFill>
+                <a:latin typeface="Archivo SemiBold"/>
+              </a:rPr>
+              <a:t>Materiales, quema, vino, café y pasabocas</a:t>
+            </a:r>
+          </a:p>
+        </p:txBody>
+      </p:sp>
+      <p:sp>
+        <p:nvSpPr>
+          <p:cNvPr id="16" name="TextBox 15"/>
+          <p:cNvSpPr txBox="1"/>
+          <p:nvPr/>
+        </p:nvSpPr>
+        <p:spPr>
+          <a:xfrm>
+            <a:off x="609600" y="14935200"/>
+            <a:ext cx="4533900" cy="209550"/>
+          </a:xfrm>
+          <a:prstGeom prst="rect">
+            <a:avLst/>
+          </a:prstGeom>
+          <a:noFill/>
+        </p:spPr>
+        <p:txBody>
+          <a:bodyPr wrap="none" anchor="t" lIns="0" rIns="0" tIns="0" bIns="0"/>
+          <a:lstStyle/>
+          <a:p>
+            <a:pPr algn="ctr">
+              <a:lnSpc>
+                <a:spcPts val="1650"/>
+              </a:lnSpc>
+            </a:pPr>
+            <a:r>
+              <a:rPr sz="1650" b="0" spc="225">
+                <a:solidFill>
+                  <a:srgbClr val="2E3A46"/>
+                </a:solidFill>
+                <a:latin typeface="Archivo SemiBold"/>
+              </a:rPr>
+              <a:t>POR PERSONA</a:t>
+            </a:r>
+          </a:p>
+        </p:txBody>
+      </p:sp>
+      <p:sp>
+        <p:nvSpPr>
+          <p:cNvPr id="17" name="TextBox 16"/>
+          <p:cNvSpPr txBox="1"/>
+          <p:nvPr/>
+        </p:nvSpPr>
+        <p:spPr>
+          <a:xfrm>
+            <a:off x="609600" y="15240000"/>
+            <a:ext cx="4533900" cy="514350"/>
+          </a:xfrm>
+          <a:prstGeom prst="rect">
+            <a:avLst/>
+          </a:prstGeom>
+          <a:noFill/>
+        </p:spPr>
+        <p:txBody>
+          <a:bodyPr wrap="none" anchor="t" lIns="0" rIns="0" tIns="0" bIns="0"/>
+          <a:lstStyle/>
+          <a:p>
+            <a:pPr algn="ctr">
+              <a:lnSpc>
+                <a:spcPts val="4050"/>
+              </a:lnSpc>
+            </a:pPr>
+            <a:r>
+              <a:rPr sz="4050" b="1" spc="-75">
+                <a:solidFill>
+                  <a:srgbClr val="2E3A46"/>
+                </a:solidFill>
+                <a:latin typeface="Archivo"/>
+              </a:rPr>
+              <a:t>$230.000</a:t>
+            </a:r>
+          </a:p>
+        </p:txBody>
+      </p:sp>
+      <p:sp>
+        <p:nvSpPr>
+          <p:cNvPr id="18" name="TextBox 17"/>
+          <p:cNvSpPr txBox="1"/>
+          <p:nvPr/>
+        </p:nvSpPr>
+        <p:spPr>
+          <a:xfrm>
+            <a:off x="5143500" y="14935200"/>
+            <a:ext cx="4533900" cy="209550"/>
+          </a:xfrm>
+          <a:prstGeom prst="rect">
+            <a:avLst/>
+          </a:prstGeom>
+          <a:noFill/>
+        </p:spPr>
+        <p:txBody>
+          <a:bodyPr wrap="none" anchor="t" lIns="0" rIns="0" tIns="0" bIns="0"/>
+          <a:lstStyle/>
+          <a:p>
+            <a:pPr algn="ctr">
+              <a:lnSpc>
+                <a:spcPts val="1650"/>
+              </a:lnSpc>
+            </a:pPr>
+            <a:r>
+              <a:rPr sz="1650" b="0" spc="225">
+                <a:solidFill>
+                  <a:srgbClr val="2E3A46"/>
+                </a:solidFill>
+                <a:latin typeface="Archivo SemiBold"/>
+              </a:rPr>
+              <a:t>RESERVAS POR WHATSAPP</a:t>
+            </a:r>
+          </a:p>
+        </p:txBody>
+      </p:sp>
+      <p:sp>
+        <p:nvSpPr>
+          <p:cNvPr id="19" name="TextBox 18"/>
+          <p:cNvSpPr txBox="1"/>
+          <p:nvPr/>
+        </p:nvSpPr>
+        <p:spPr>
+          <a:xfrm>
+            <a:off x="5143500" y="15278100"/>
+            <a:ext cx="4533900" cy="419100"/>
+          </a:xfrm>
+          <a:prstGeom prst="rect">
+            <a:avLst/>
+          </a:prstGeom>
+          <a:noFill/>
+        </p:spPr>
+        <p:txBody>
+          <a:bodyPr wrap="none" anchor="t" lIns="0" rIns="0" tIns="0" bIns="0"/>
+          <a:lstStyle/>
+          <a:p>
+            <a:pPr algn="ctr">
+              <a:lnSpc>
+                <a:spcPts val="3300"/>
+              </a:lnSpc>
+            </a:pPr>
+            <a:r>
+              <a:rPr sz="3300" b="0">
                 <a:solidFill>
                   <a:srgbClr val="2E3A46"/>
                 </a:solidFill>
@@ -4212,7 +4339,7 @@
         <p:spPr>
           <a:xfrm>
             <a:off x="2038350" y="12458700"/>
-            <a:ext cx="5853559" cy="381000"/>
+            <a:ext cx="6464945" cy="381000"/>
           </a:xfrm>
           <a:prstGeom prst="rect">
             <a:avLst/>
@@ -4231,11 +4358,11 @@
             <a:r>
               <a:rPr sz="3000" b="0" spc="-38">
                 <a:solidFill>
-                  <a:srgbClr val="6B7480"/>
-                </a:solidFill>
-                <a:latin typeface="Archivo Medium"/>
+                  <a:srgbClr val="2E3A46"/>
+                </a:solidFill>
+                <a:latin typeface="Archivo SemiBold"/>
               </a:rPr>
-              <a:t>[Aperitivos y vino · por confirmar]</a:t>
+              <a:t>Vino, café y pasabocas para la tarde</a:t>
             </a:r>
           </a:p>
         </p:txBody>

</xml_diff>

<commit_message>
Taller: carrusel Cómo participar, mensajes de WhatsApp, respuestas confirmadas y 5 pocillos y 5 platos en la historia
Co-Authored-By: Claude Opus 5.5 <noreply@anthropic.com>
Claude-Session: https://claude.ai/code/session_01FV7y6XEE3x9ogCMyfe3pnd
</commit_message>
<xml_diff>
--- a/docs/sesion-2026-10-02/canva-taller-ceramica/historia-4-invitacion/historias-taller-ceramica.pptx
+++ b/docs/sesion-2026-10-02/canva-taller-ceramica/historia-4-invitacion/historias-taller-ceramica.pptx
@@ -4043,7 +4043,7 @@
         <p:spPr>
           <a:xfrm>
             <a:off x="2038350" y="7962900"/>
-            <a:ext cx="5589984" cy="381000"/>
+            <a:ext cx="5588347" cy="381000"/>
           </a:xfrm>
           <a:prstGeom prst="rect">
             <a:avLst/>
@@ -4066,7 +4066,7 @@
                 </a:solidFill>
                 <a:latin typeface="Archivo SemiBold"/>
               </a:rPr>
-              <a:t>4 pocillos y 4 platos para pintar</a:t>
+              <a:t>5 pocillos y 5 platos para pintar</a:t>
             </a:r>
           </a:p>
         </p:txBody>

</xml_diff>

<commit_message>
Taller: 4 pocillos y 4 platos con repuestos, saldo el día del taller, cambio de nombre hasta el 16 oct, entrega 2–3 semanas, WhatsApp de reservas
Co-Authored-By: Claude Opus 5.5 <noreply@anthropic.com>
Claude-Session: https://claude.ai/code/session_01FV7y6XEE3x9ogCMyfe3pnd
</commit_message>
<xml_diff>
--- a/docs/sesion-2026-10-02/canva-taller-ceramica/historia-4-invitacion/historias-taller-ceramica.pptx
+++ b/docs/sesion-2026-10-02/canva-taller-ceramica/historia-4-invitacion/historias-taller-ceramica.pptx
@@ -3744,7 +3744,7 @@
         <p:spPr>
           <a:xfrm>
             <a:off x="5143500" y="15278100"/>
-            <a:ext cx="4533900" cy="419100"/>
+            <a:ext cx="4533900" cy="381000"/>
           </a:xfrm>
           <a:prstGeom prst="rect">
             <a:avLst/>
@@ -3757,17 +3757,17 @@
           <a:p>
             <a:pPr algn="ctr">
               <a:lnSpc>
-                <a:spcPts val="3300"/>
+                <a:spcPts val="3000"/>
               </a:lnSpc>
             </a:pPr>
             <a:r>
-              <a:rPr sz="3300" b="0">
+              <a:rPr sz="3000" b="0">
                 <a:solidFill>
                   <a:srgbClr val="2E3A46"/>
                 </a:solidFill>
                 <a:latin typeface="Archivo SemiBold"/>
               </a:rPr>
-              <a:t>[número]</a:t>
+              <a:t>316 533 3125</a:t>
             </a:r>
           </a:p>
         </p:txBody>
@@ -4043,7 +4043,7 @@
         <p:spPr>
           <a:xfrm>
             <a:off x="2038350" y="7962900"/>
-            <a:ext cx="5588347" cy="381000"/>
+            <a:ext cx="5589984" cy="381000"/>
           </a:xfrm>
           <a:prstGeom prst="rect">
             <a:avLst/>
@@ -4066,7 +4066,7 @@
                 </a:solidFill>
                 <a:latin typeface="Archivo SemiBold"/>
               </a:rPr>
-              <a:t>5 pocillos y 5 platos para pintar</a:t>
+              <a:t>4 pocillos y 4 platos para pintar</a:t>
             </a:r>
           </a:p>
         </p:txBody>

</xml_diff>